<commit_message>
Literally hell of a second lesson
</commit_message>
<xml_diff>
--- a/0.0 - Infrastructure around coding - VS Code/2.0 - Sololearn review.pptx
+++ b/0.0 - Infrastructure around coding - VS Code/2.0 - Sololearn review.pptx
@@ -5,10 +5,10 @@
     <p:sldMasterId id="2147483696" r:id="rId4"/>
   </p:sldMasterIdLst>
   <p:notesMasterIdLst>
-    <p:notesMasterId r:id="rId20"/>
+    <p:notesMasterId r:id="rId21"/>
   </p:notesMasterIdLst>
   <p:handoutMasterIdLst>
-    <p:handoutMasterId r:id="rId21"/>
+    <p:handoutMasterId r:id="rId22"/>
   </p:handoutMasterIdLst>
   <p:sldIdLst>
     <p:sldId id="306" r:id="rId5"/>
@@ -24,8 +24,9 @@
     <p:sldId id="320" r:id="rId15"/>
     <p:sldId id="321" r:id="rId16"/>
     <p:sldId id="322" r:id="rId17"/>
-    <p:sldId id="295" r:id="rId18"/>
-    <p:sldId id="323" r:id="rId19"/>
+    <p:sldId id="324" r:id="rId18"/>
+    <p:sldId id="295" r:id="rId19"/>
+    <p:sldId id="323" r:id="rId20"/>
   </p:sldIdLst>
   <p:sldSz cx="12192000" cy="6858000"/>
   <p:notesSz cx="6858000" cy="9144000"/>
@@ -251,7 +252,7 @@
           <a:p>
             <a:fld id="{5536B27D-C1ED-4C55-9062-2279210E96ED}" type="datetime1">
               <a:rPr lang="en-GB" smtClean="0"/>
-              <a:t>08/08/2025</a:t>
+              <a:t>17/04/2026</a:t>
             </a:fld>
             <a:endParaRPr lang="en-GB" dirty="0"/>
           </a:p>
@@ -431,7 +432,7 @@
             <a:fld id="{B461EAF8-BEF3-4EDD-99CF-6435314FE1C9}" type="datetime1">
               <a:rPr lang="en-GB" smtClean="0"/>
               <a:pPr/>
-              <a:t>08/08/2025</a:t>
+              <a:t>17/04/2026</a:t>
             </a:fld>
             <a:endParaRPr lang="en-GB" dirty="0"/>
           </a:p>
@@ -877,6 +878,115 @@
   <p:cSld>
     <p:spTree>
       <p:nvGrpSpPr>
+        <p:cNvPr id="1" name="">
+          <a:extLst>
+            <a:ext uri="{FF2B5EF4-FFF2-40B4-BE49-F238E27FC236}">
+              <a16:creationId xmlns:a16="http://schemas.microsoft.com/office/drawing/2014/main" id="{3F5A6B0D-0FD2-0A09-4377-39FA601BD105}"/>
+            </a:ext>
+          </a:extLst>
+        </p:cNvPr>
+        <p:cNvGrpSpPr/>
+        <p:nvPr/>
+      </p:nvGrpSpPr>
+      <p:grpSpPr>
+        <a:xfrm>
+          <a:off x="0" y="0"/>
+          <a:ext cx="0" cy="0"/>
+          <a:chOff x="0" y="0"/>
+          <a:chExt cx="0" cy="0"/>
+        </a:xfrm>
+      </p:grpSpPr>
+      <p:sp>
+        <p:nvSpPr>
+          <p:cNvPr id="2" name="Slide Image Placeholder 1">
+            <a:extLst>
+              <a:ext uri="{FF2B5EF4-FFF2-40B4-BE49-F238E27FC236}">
+                <a16:creationId xmlns:a16="http://schemas.microsoft.com/office/drawing/2014/main" id="{1B7180B6-3237-23DF-D9EB-1FC62ABF8B79}"/>
+              </a:ext>
+            </a:extLst>
+          </p:cNvPr>
+          <p:cNvSpPr>
+            <a:spLocks noGrp="1" noRot="1" noChangeAspect="1"/>
+          </p:cNvSpPr>
+          <p:nvPr>
+            <p:ph type="sldImg"/>
+          </p:nvPr>
+        </p:nvSpPr>
+        <p:spPr/>
+      </p:sp>
+      <p:sp>
+        <p:nvSpPr>
+          <p:cNvPr id="3" name="Notes Placeholder 2">
+            <a:extLst>
+              <a:ext uri="{FF2B5EF4-FFF2-40B4-BE49-F238E27FC236}">
+                <a16:creationId xmlns:a16="http://schemas.microsoft.com/office/drawing/2014/main" id="{7B3C943B-0913-D3CA-9719-CE0BF1581C48}"/>
+              </a:ext>
+            </a:extLst>
+          </p:cNvPr>
+          <p:cNvSpPr>
+            <a:spLocks noGrp="1"/>
+          </p:cNvSpPr>
+          <p:nvPr>
+            <p:ph type="body" idx="1"/>
+          </p:nvPr>
+        </p:nvSpPr>
+        <p:spPr/>
+        <p:txBody>
+          <a:bodyPr/>
+          <a:lstStyle/>
+          <a:p>
+            <a:endParaRPr lang="en-GB"/>
+          </a:p>
+        </p:txBody>
+      </p:sp>
+      <p:sp>
+        <p:nvSpPr>
+          <p:cNvPr id="4" name="Slide Number Placeholder 3">
+            <a:extLst>
+              <a:ext uri="{FF2B5EF4-FFF2-40B4-BE49-F238E27FC236}">
+                <a16:creationId xmlns:a16="http://schemas.microsoft.com/office/drawing/2014/main" id="{22096223-B91B-AAAB-43D4-7845A6870045}"/>
+              </a:ext>
+            </a:extLst>
+          </p:cNvPr>
+          <p:cNvSpPr>
+            <a:spLocks noGrp="1"/>
+          </p:cNvSpPr>
+          <p:nvPr>
+            <p:ph type="sldNum" sz="quarter" idx="5"/>
+          </p:nvPr>
+        </p:nvSpPr>
+        <p:spPr/>
+        <p:txBody>
+          <a:bodyPr/>
+          <a:lstStyle/>
+          <a:p>
+            <a:pPr rtl="0"/>
+            <a:fld id="{D5939589-3E79-4C82-AA4A-FE78234FAA59}" type="slidenum">
+              <a:rPr lang="en-GB" smtClean="0"/>
+              <a:t>14</a:t>
+            </a:fld>
+            <a:endParaRPr lang="en-GB"/>
+          </a:p>
+        </p:txBody>
+      </p:sp>
+    </p:spTree>
+    <p:extLst>
+      <p:ext uri="{BB962C8B-B14F-4D97-AF65-F5344CB8AC3E}">
+        <p14:creationId xmlns:p14="http://schemas.microsoft.com/office/powerpoint/2010/main" val="2040075261"/>
+      </p:ext>
+    </p:extLst>
+  </p:cSld>
+  <p:clrMapOvr>
+    <a:masterClrMapping/>
+  </p:clrMapOvr>
+</p:notes>
+</file>
+
+<file path=ppt/notesSlides/notesSlide4.xml><?xml version="1.0" encoding="utf-8"?>
+<p:notes xmlns:a="http://schemas.openxmlformats.org/drawingml/2006/main" xmlns:r="http://schemas.openxmlformats.org/officeDocument/2006/relationships" xmlns:p="http://schemas.openxmlformats.org/presentationml/2006/main">
+  <p:cSld>
+    <p:spTree>
+      <p:nvGrpSpPr>
         <p:cNvPr id="1" name=""/>
         <p:cNvGrpSpPr/>
         <p:nvPr/>
@@ -938,7 +1048,7 @@
             <a:pPr rtl="0"/>
             <a:fld id="{D5939589-3E79-4C82-AA4A-FE78234FAA59}" type="slidenum">
               <a:rPr lang="en-GB" smtClean="0"/>
-              <a:t>14</a:t>
+              <a:t>15</a:t>
             </a:fld>
             <a:endParaRPr lang="en-GB"/>
           </a:p>
@@ -13407,10 +13517,10 @@
           <p:nvPr/>
         </p:nvPicPr>
         <p:blipFill>
-          <a:blip r:embed="rId2">
+          <a:blip>
             <a:extLst>
               <a:ext uri="{96DAC541-7B7A-43D3-8B79-37D633B846F1}">
-                <asvg:svgBlip xmlns:asvg="http://schemas.microsoft.com/office/drawing/2016/SVG/main" r:embed="rId3"/>
+                <asvg:svgBlip xmlns:asvg="http://schemas.microsoft.com/office/drawing/2016/SVG/main" r:embed="rId2"/>
               </a:ext>
             </a:extLst>
           </a:blip>
@@ -13443,10 +13553,10 @@
           <p:nvPr/>
         </p:nvPicPr>
         <p:blipFill>
-          <a:blip r:embed="rId4">
+          <a:blip>
             <a:extLst>
               <a:ext uri="{96DAC541-7B7A-43D3-8B79-37D633B846F1}">
-                <asvg:svgBlip xmlns:asvg="http://schemas.microsoft.com/office/drawing/2016/SVG/main" r:embed="rId5"/>
+                <asvg:svgBlip xmlns:asvg="http://schemas.microsoft.com/office/drawing/2016/SVG/main" r:embed="rId3"/>
               </a:ext>
             </a:extLst>
           </a:blip>
@@ -13479,10 +13589,10 @@
           <p:nvPr/>
         </p:nvPicPr>
         <p:blipFill>
-          <a:blip r:embed="rId6">
+          <a:blip>
             <a:extLst>
               <a:ext uri="{96DAC541-7B7A-43D3-8B79-37D633B846F1}">
-                <asvg:svgBlip xmlns:asvg="http://schemas.microsoft.com/office/drawing/2016/SVG/main" r:embed="rId7"/>
+                <asvg:svgBlip xmlns:asvg="http://schemas.microsoft.com/office/drawing/2016/SVG/main" r:embed="rId4"/>
               </a:ext>
             </a:extLst>
           </a:blip>
@@ -13515,10 +13625,10 @@
           <p:nvPr/>
         </p:nvPicPr>
         <p:blipFill>
-          <a:blip r:embed="rId8">
+          <a:blip>
             <a:extLst>
               <a:ext uri="{96DAC541-7B7A-43D3-8B79-37D633B846F1}">
-                <asvg:svgBlip xmlns:asvg="http://schemas.microsoft.com/office/drawing/2016/SVG/main" r:embed="rId9"/>
+                <asvg:svgBlip xmlns:asvg="http://schemas.microsoft.com/office/drawing/2016/SVG/main" r:embed="rId5"/>
               </a:ext>
             </a:extLst>
           </a:blip>
@@ -13551,10 +13661,10 @@
           <p:nvPr/>
         </p:nvPicPr>
         <p:blipFill>
-          <a:blip r:embed="rId10">
+          <a:blip>
             <a:extLst>
               <a:ext uri="{96DAC541-7B7A-43D3-8B79-37D633B846F1}">
-                <asvg:svgBlip xmlns:asvg="http://schemas.microsoft.com/office/drawing/2016/SVG/main" r:embed="rId11"/>
+                <asvg:svgBlip xmlns:asvg="http://schemas.microsoft.com/office/drawing/2016/SVG/main" r:embed="rId6"/>
               </a:ext>
             </a:extLst>
           </a:blip>
@@ -13586,6 +13696,1815 @@
 </file>
 
 <file path=ppt/slides/slide14.xml><?xml version="1.0" encoding="utf-8"?>
+<p:sld xmlns:a="http://schemas.openxmlformats.org/drawingml/2006/main" xmlns:r="http://schemas.openxmlformats.org/officeDocument/2006/relationships" xmlns:p="http://schemas.openxmlformats.org/presentationml/2006/main" show="0">
+  <p:cSld>
+    <p:spTree>
+      <p:nvGrpSpPr>
+        <p:cNvPr id="1" name="">
+          <a:extLst>
+            <a:ext uri="{FF2B5EF4-FFF2-40B4-BE49-F238E27FC236}">
+              <a16:creationId xmlns:a16="http://schemas.microsoft.com/office/drawing/2014/main" id="{332DD237-4EE8-4CAC-E3C3-1604D63E5F15}"/>
+            </a:ext>
+          </a:extLst>
+        </p:cNvPr>
+        <p:cNvGrpSpPr/>
+        <p:nvPr/>
+      </p:nvGrpSpPr>
+      <p:grpSpPr>
+        <a:xfrm>
+          <a:off x="0" y="0"/>
+          <a:ext cx="0" cy="0"/>
+          <a:chOff x="0" y="0"/>
+          <a:chExt cx="0" cy="0"/>
+        </a:xfrm>
+      </p:grpSpPr>
+      <p:sp>
+        <p:nvSpPr>
+          <p:cNvPr id="4" name="Title 3">
+            <a:extLst>
+              <a:ext uri="{FF2B5EF4-FFF2-40B4-BE49-F238E27FC236}">
+                <a16:creationId xmlns:a16="http://schemas.microsoft.com/office/drawing/2014/main" id="{38917B62-D3CF-E986-0ACD-8554E81ADD59}"/>
+              </a:ext>
+            </a:extLst>
+          </p:cNvPr>
+          <p:cNvSpPr>
+            <a:spLocks noGrp="1"/>
+          </p:cNvSpPr>
+          <p:nvPr>
+            <p:ph type="title"/>
+          </p:nvPr>
+        </p:nvSpPr>
+        <p:spPr/>
+        <p:txBody>
+          <a:bodyPr rtlCol="0">
+            <a:normAutofit/>
+          </a:bodyPr>
+          <a:lstStyle/>
+          <a:p>
+            <a:pPr rtl="0"/>
+            <a:r>
+              <a:rPr lang="en-GB" sz="5400" dirty="0"/>
+              <a:t>Summary</a:t>
+            </a:r>
+          </a:p>
+        </p:txBody>
+      </p:sp>
+      <p:graphicFrame>
+        <p:nvGraphicFramePr>
+          <p:cNvPr id="5" name="Table 5">
+            <a:extLst>
+              <a:ext uri="{FF2B5EF4-FFF2-40B4-BE49-F238E27FC236}">
+                <a16:creationId xmlns:a16="http://schemas.microsoft.com/office/drawing/2014/main" id="{B44DA1E4-D5F5-F9FF-3B2A-75035174AA8E}"/>
+              </a:ext>
+            </a:extLst>
+          </p:cNvPr>
+          <p:cNvGraphicFramePr>
+            <a:graphicFrameLocks noGrp="1"/>
+          </p:cNvGraphicFramePr>
+          <p:nvPr>
+            <p:ph idx="1"/>
+          </p:nvPr>
+        </p:nvGraphicFramePr>
+        <p:xfrm>
+          <a:off x="1636776" y="1828691"/>
+          <a:ext cx="9262873" cy="4031334"/>
+        </p:xfrm>
+        <a:graphic>
+          <a:graphicData uri="http://schemas.openxmlformats.org/drawingml/2006/table">
+            <a:tbl>
+              <a:tblPr firstRow="1">
+                <a:tableStyleId>{5C22544A-7EE6-4342-B048-85BDC9FD1C3A}</a:tableStyleId>
+              </a:tblPr>
+              <a:tblGrid>
+                <a:gridCol w="3090672">
+                  <a:extLst>
+                    <a:ext uri="{9D8B030D-6E8A-4147-A177-3AD203B41FA5}">
+                      <a16:colId xmlns:a16="http://schemas.microsoft.com/office/drawing/2014/main" val="3715394682"/>
+                    </a:ext>
+                  </a:extLst>
+                </a:gridCol>
+                <a:gridCol w="2001050">
+                  <a:extLst>
+                    <a:ext uri="{9D8B030D-6E8A-4147-A177-3AD203B41FA5}">
+                      <a16:colId xmlns:a16="http://schemas.microsoft.com/office/drawing/2014/main" val="4203886316"/>
+                    </a:ext>
+                  </a:extLst>
+                </a:gridCol>
+                <a:gridCol w="2545861">
+                  <a:extLst>
+                    <a:ext uri="{9D8B030D-6E8A-4147-A177-3AD203B41FA5}">
+                      <a16:colId xmlns:a16="http://schemas.microsoft.com/office/drawing/2014/main" val="1368357775"/>
+                    </a:ext>
+                  </a:extLst>
+                </a:gridCol>
+                <a:gridCol w="1625290">
+                  <a:extLst>
+                    <a:ext uri="{9D8B030D-6E8A-4147-A177-3AD203B41FA5}">
+                      <a16:colId xmlns:a16="http://schemas.microsoft.com/office/drawing/2014/main" val="538162733"/>
+                    </a:ext>
+                  </a:extLst>
+                </a:gridCol>
+              </a:tblGrid>
+              <a:tr h="586491">
+                <a:tc>
+                  <a:txBody>
+                    <a:bodyPr/>
+                    <a:lstStyle/>
+                    <a:p>
+                      <a:endParaRPr lang="en-GB" b="1" dirty="0"/>
+                    </a:p>
+                  </a:txBody>
+                  <a:tcPr>
+                    <a:lnL w="12700" cmpd="sng">
+                      <a:noFill/>
+                    </a:lnL>
+                    <a:lnR w="12700" cmpd="sng">
+                      <a:noFill/>
+                    </a:lnR>
+                    <a:lnT w="12700" cmpd="sng">
+                      <a:noFill/>
+                    </a:lnT>
+                    <a:lnB w="38100" cmpd="sng">
+                      <a:noFill/>
+                    </a:lnB>
+                    <a:lnTlToBr w="12700" cmpd="sng">
+                      <a:noFill/>
+                      <a:prstDash val="solid"/>
+                    </a:lnTlToBr>
+                    <a:lnBlToTr w="12700" cmpd="sng">
+                      <a:noFill/>
+                      <a:prstDash val="solid"/>
+                    </a:lnBlToTr>
+                    <a:noFill/>
+                  </a:tcPr>
+                </a:tc>
+                <a:tc>
+                  <a:txBody>
+                    <a:bodyPr/>
+                    <a:lstStyle/>
+                    <a:p>
+                      <a:r>
+                        <a:rPr lang="en-GB" dirty="0">
+                          <a:solidFill>
+                            <a:schemeClr val="accent1">
+                              <a:lumMod val="60000"/>
+                              <a:lumOff val="40000"/>
+                            </a:schemeClr>
+                          </a:solidFill>
+                        </a:rPr>
+                        <a:t>LearnPython.org</a:t>
+                      </a:r>
+                    </a:p>
+                  </a:txBody>
+                  <a:tcPr>
+                    <a:lnL w="12700" cmpd="sng">
+                      <a:noFill/>
+                    </a:lnL>
+                    <a:lnR w="12700" cmpd="sng">
+                      <a:noFill/>
+                    </a:lnR>
+                    <a:lnT w="12700" cmpd="sng">
+                      <a:noFill/>
+                    </a:lnT>
+                    <a:lnB w="38100" cmpd="sng">
+                      <a:noFill/>
+                    </a:lnB>
+                    <a:lnTlToBr w="12700" cmpd="sng">
+                      <a:noFill/>
+                      <a:prstDash val="solid"/>
+                    </a:lnTlToBr>
+                    <a:lnBlToTr w="12700" cmpd="sng">
+                      <a:noFill/>
+                      <a:prstDash val="solid"/>
+                    </a:lnBlToTr>
+                    <a:solidFill>
+                      <a:schemeClr val="accent1">
+                        <a:lumMod val="40000"/>
+                        <a:lumOff val="60000"/>
+                      </a:schemeClr>
+                    </a:solidFill>
+                  </a:tcPr>
+                </a:tc>
+                <a:tc>
+                  <a:txBody>
+                    <a:bodyPr/>
+                    <a:lstStyle/>
+                    <a:p>
+                      <a:pPr marL="0" algn="l" defTabSz="914400" rtl="0" eaLnBrk="1" latinLnBrk="0" hangingPunct="1"/>
+                      <a:r>
+                        <a:rPr lang="en-GB" sz="1800" b="1" kern="1200" dirty="0" err="1">
+                          <a:solidFill>
+                            <a:schemeClr val="lt1"/>
+                          </a:solidFill>
+                          <a:latin typeface="+mn-lt"/>
+                          <a:ea typeface="+mn-ea"/>
+                          <a:cs typeface="+mn-cs"/>
+                        </a:rPr>
+                        <a:t>Sololearn</a:t>
+                      </a:r>
+                      <a:r>
+                        <a:rPr lang="en-GB" sz="1800" b="1" kern="1200" dirty="0">
+                          <a:solidFill>
+                            <a:schemeClr val="lt1"/>
+                          </a:solidFill>
+                          <a:latin typeface="+mn-lt"/>
+                          <a:ea typeface="+mn-ea"/>
+                          <a:cs typeface="+mn-cs"/>
+                        </a:rPr>
+                        <a:t> (Free)</a:t>
+                      </a:r>
+                    </a:p>
+                    <a:p>
+                      <a:pPr marL="0" algn="l" defTabSz="914400" rtl="0" eaLnBrk="1" latinLnBrk="0" hangingPunct="1"/>
+                      <a:r>
+                        <a:rPr lang="en-GB" sz="1800" b="1" kern="1200" dirty="0">
+                          <a:solidFill>
+                            <a:schemeClr val="lt1"/>
+                          </a:solidFill>
+                          <a:latin typeface="+mn-lt"/>
+                          <a:ea typeface="+mn-ea"/>
+                          <a:cs typeface="+mn-cs"/>
+                        </a:rPr>
+                        <a:t>Python Introduction</a:t>
+                      </a:r>
+                    </a:p>
+                  </a:txBody>
+                  <a:tcPr>
+                    <a:lnL w="12700" cmpd="sng">
+                      <a:noFill/>
+                    </a:lnL>
+                    <a:lnR w="12700" cmpd="sng">
+                      <a:noFill/>
+                    </a:lnR>
+                    <a:lnT w="12700" cmpd="sng">
+                      <a:noFill/>
+                    </a:lnT>
+                    <a:lnB w="38100" cmpd="sng">
+                      <a:noFill/>
+                    </a:lnB>
+                    <a:lnTlToBr w="12700" cmpd="sng">
+                      <a:noFill/>
+                      <a:prstDash val="solid"/>
+                    </a:lnTlToBr>
+                    <a:lnBlToTr w="12700" cmpd="sng">
+                      <a:noFill/>
+                      <a:prstDash val="solid"/>
+                    </a:lnBlToTr>
+                    <a:solidFill>
+                      <a:schemeClr val="accent5"/>
+                    </a:solidFill>
+                  </a:tcPr>
+                </a:tc>
+                <a:tc>
+                  <a:txBody>
+                    <a:bodyPr/>
+                    <a:lstStyle/>
+                    <a:p>
+                      <a:pPr algn="ctr" rtl="0"/>
+                      <a:r>
+                        <a:rPr lang="en-GB" sz="1400" noProof="0" dirty="0">
+                          <a:solidFill>
+                            <a:schemeClr val="accent3">
+                              <a:lumMod val="60000"/>
+                              <a:lumOff val="40000"/>
+                            </a:schemeClr>
+                          </a:solidFill>
+                        </a:rPr>
+                        <a:t>Next course will go here</a:t>
+                      </a:r>
+                    </a:p>
+                  </a:txBody>
+                  <a:tcPr anchor="ctr">
+                    <a:lnL w="12700" cmpd="sng">
+                      <a:noFill/>
+                    </a:lnL>
+                    <a:lnR w="12700" cmpd="sng">
+                      <a:noFill/>
+                    </a:lnR>
+                    <a:lnT w="12700" cmpd="sng">
+                      <a:noFill/>
+                    </a:lnT>
+                    <a:lnB w="38100" cmpd="sng">
+                      <a:noFill/>
+                    </a:lnB>
+                    <a:lnTlToBr w="12700" cmpd="sng">
+                      <a:noFill/>
+                      <a:prstDash val="solid"/>
+                    </a:lnTlToBr>
+                    <a:lnBlToTr w="12700" cmpd="sng">
+                      <a:noFill/>
+                      <a:prstDash val="solid"/>
+                    </a:lnBlToTr>
+                    <a:solidFill>
+                      <a:schemeClr val="accent3"/>
+                    </a:solidFill>
+                  </a:tcPr>
+                </a:tc>
+                <a:extLst>
+                  <a:ext uri="{0D108BD9-81ED-4DB2-BD59-A6C34878D82A}">
+                    <a16:rowId xmlns:a16="http://schemas.microsoft.com/office/drawing/2014/main" val="342729846"/>
+                  </a:ext>
+                </a:extLst>
+              </a:tr>
+              <a:tr h="376806">
+                <a:tc>
+                  <a:txBody>
+                    <a:bodyPr/>
+                    <a:lstStyle/>
+                    <a:p>
+                      <a:pPr marL="0" marR="0" lvl="0" indent="0" algn="l" defTabSz="914400" rtl="0" eaLnBrk="1" fontAlgn="auto" latinLnBrk="0" hangingPunct="1">
+                        <a:lnSpc>
+                          <a:spcPct val="100000"/>
+                        </a:lnSpc>
+                        <a:spcBef>
+                          <a:spcPts val="0"/>
+                        </a:spcBef>
+                        <a:spcAft>
+                          <a:spcPts val="0"/>
+                        </a:spcAft>
+                        <a:buClrTx/>
+                        <a:buSzTx/>
+                        <a:buFontTx/>
+                        <a:buNone/>
+                        <a:tabLst/>
+                        <a:defRPr/>
+                      </a:pPr>
+                      <a:r>
+                        <a:rPr lang="en-US" b="1" dirty="0"/>
+                        <a:t>Context &amp; Relevance</a:t>
+                      </a:r>
+                    </a:p>
+                  </a:txBody>
+                  <a:tcPr>
+                    <a:lnL w="12700" cmpd="sng">
+                      <a:noFill/>
+                    </a:lnL>
+                    <a:lnR w="6350" cap="flat" cmpd="sng" algn="ctr">
+                      <a:solidFill>
+                        <a:schemeClr val="accent1"/>
+                      </a:solidFill>
+                      <a:prstDash val="solid"/>
+                      <a:round/>
+                      <a:headEnd type="none" w="med" len="med"/>
+                      <a:tailEnd type="none" w="med" len="med"/>
+                    </a:lnR>
+                    <a:lnT w="3175" cap="flat" cmpd="sng" algn="ctr">
+                      <a:noFill/>
+                      <a:prstDash val="solid"/>
+                      <a:round/>
+                      <a:headEnd type="none" w="med" len="med"/>
+                      <a:tailEnd type="none" w="med" len="med"/>
+                    </a:lnT>
+                    <a:lnB w="12700" cmpd="sng">
+                      <a:noFill/>
+                    </a:lnB>
+                    <a:lnTlToBr w="12700" cmpd="sng">
+                      <a:noFill/>
+                      <a:prstDash val="solid"/>
+                    </a:lnTlToBr>
+                    <a:lnBlToTr w="12700" cmpd="sng">
+                      <a:noFill/>
+                      <a:prstDash val="solid"/>
+                    </a:lnBlToTr>
+                    <a:noFill/>
+                  </a:tcPr>
+                </a:tc>
+                <a:tc>
+                  <a:txBody>
+                    <a:bodyPr/>
+                    <a:lstStyle/>
+                    <a:p>
+                      <a:r>
+                        <a:rPr lang="en-GB" dirty="0">
+                          <a:solidFill>
+                            <a:schemeClr val="bg1">
+                              <a:lumMod val="65000"/>
+                            </a:schemeClr>
+                          </a:solidFill>
+                        </a:rPr>
+                        <a:t>2</a:t>
+                      </a:r>
+                    </a:p>
+                  </a:txBody>
+                  <a:tcPr>
+                    <a:lnL w="6350" cap="flat" cmpd="sng" algn="ctr">
+                      <a:solidFill>
+                        <a:schemeClr val="accent1"/>
+                      </a:solidFill>
+                      <a:prstDash val="solid"/>
+                      <a:round/>
+                      <a:headEnd type="none" w="med" len="med"/>
+                      <a:tailEnd type="none" w="med" len="med"/>
+                    </a:lnL>
+                    <a:lnR w="6350" cap="flat" cmpd="sng" algn="ctr">
+                      <a:solidFill>
+                        <a:schemeClr val="accent5"/>
+                      </a:solidFill>
+                      <a:prstDash val="solid"/>
+                      <a:round/>
+                      <a:headEnd type="none" w="med" len="med"/>
+                      <a:tailEnd type="none" w="med" len="med"/>
+                    </a:lnR>
+                    <a:lnT w="3175" cap="flat" cmpd="sng" algn="ctr">
+                      <a:noFill/>
+                      <a:prstDash val="solid"/>
+                      <a:round/>
+                      <a:headEnd type="none" w="med" len="med"/>
+                      <a:tailEnd type="none" w="med" len="med"/>
+                    </a:lnT>
+                    <a:lnB w="12700" cmpd="sng">
+                      <a:noFill/>
+                    </a:lnB>
+                    <a:lnTlToBr w="12700" cmpd="sng">
+                      <a:noFill/>
+                      <a:prstDash val="solid"/>
+                    </a:lnTlToBr>
+                    <a:lnBlToTr w="12700" cmpd="sng">
+                      <a:noFill/>
+                      <a:prstDash val="solid"/>
+                    </a:lnBlToTr>
+                    <a:noFill/>
+                  </a:tcPr>
+                </a:tc>
+                <a:tc>
+                  <a:txBody>
+                    <a:bodyPr/>
+                    <a:lstStyle/>
+                    <a:p>
+                      <a:r>
+                        <a:rPr lang="en-GB" dirty="0"/>
+                        <a:t>3</a:t>
+                      </a:r>
+                    </a:p>
+                  </a:txBody>
+                  <a:tcPr>
+                    <a:lnL w="6350" cap="flat" cmpd="sng" algn="ctr">
+                      <a:solidFill>
+                        <a:schemeClr val="accent5"/>
+                      </a:solidFill>
+                      <a:prstDash val="solid"/>
+                      <a:round/>
+                      <a:headEnd type="none" w="med" len="med"/>
+                      <a:tailEnd type="none" w="med" len="med"/>
+                    </a:lnL>
+                    <a:lnR w="6350" cap="flat" cmpd="sng" algn="ctr">
+                      <a:solidFill>
+                        <a:schemeClr val="accent3"/>
+                      </a:solidFill>
+                      <a:prstDash val="solid"/>
+                      <a:round/>
+                      <a:headEnd type="none" w="med" len="med"/>
+                      <a:tailEnd type="none" w="med" len="med"/>
+                    </a:lnR>
+                    <a:lnT w="3175" cap="flat" cmpd="sng" algn="ctr">
+                      <a:noFill/>
+                      <a:prstDash val="solid"/>
+                      <a:round/>
+                      <a:headEnd type="none" w="med" len="med"/>
+                      <a:tailEnd type="none" w="med" len="med"/>
+                    </a:lnT>
+                    <a:lnB w="12700" cmpd="sng">
+                      <a:noFill/>
+                    </a:lnB>
+                    <a:lnTlToBr w="12700" cmpd="sng">
+                      <a:noFill/>
+                      <a:prstDash val="solid"/>
+                    </a:lnTlToBr>
+                    <a:lnBlToTr w="12700" cmpd="sng">
+                      <a:noFill/>
+                      <a:prstDash val="solid"/>
+                    </a:lnBlToTr>
+                    <a:noFill/>
+                  </a:tcPr>
+                </a:tc>
+                <a:tc>
+                  <a:txBody>
+                    <a:bodyPr/>
+                    <a:lstStyle/>
+                    <a:p>
+                      <a:pPr algn="ctr" rtl="0"/>
+                      <a:endParaRPr lang="en-GB" noProof="0" dirty="0"/>
+                    </a:p>
+                  </a:txBody>
+                  <a:tcPr anchor="ctr">
+                    <a:lnL w="6350" cap="flat" cmpd="sng" algn="ctr">
+                      <a:solidFill>
+                        <a:schemeClr val="accent3"/>
+                      </a:solidFill>
+                      <a:prstDash val="solid"/>
+                      <a:round/>
+                      <a:headEnd type="none" w="med" len="med"/>
+                      <a:tailEnd type="none" w="med" len="med"/>
+                    </a:lnL>
+                    <a:lnR w="6350" cap="flat" cmpd="sng" algn="ctr">
+                      <a:solidFill>
+                        <a:schemeClr val="accent4"/>
+                      </a:solidFill>
+                      <a:prstDash val="solid"/>
+                      <a:round/>
+                      <a:headEnd type="none" w="med" len="med"/>
+                      <a:tailEnd type="none" w="med" len="med"/>
+                    </a:lnR>
+                    <a:lnT w="3175" cap="flat" cmpd="sng" algn="ctr">
+                      <a:noFill/>
+                      <a:prstDash val="solid"/>
+                      <a:round/>
+                      <a:headEnd type="none" w="med" len="med"/>
+                      <a:tailEnd type="none" w="med" len="med"/>
+                    </a:lnT>
+                    <a:lnB w="12700" cmpd="sng">
+                      <a:noFill/>
+                    </a:lnB>
+                    <a:lnTlToBr w="12700" cmpd="sng">
+                      <a:noFill/>
+                      <a:prstDash val="solid"/>
+                    </a:lnTlToBr>
+                    <a:lnBlToTr w="12700" cmpd="sng">
+                      <a:noFill/>
+                      <a:prstDash val="solid"/>
+                    </a:lnBlToTr>
+                    <a:noFill/>
+                  </a:tcPr>
+                </a:tc>
+                <a:extLst>
+                  <a:ext uri="{0D108BD9-81ED-4DB2-BD59-A6C34878D82A}">
+                    <a16:rowId xmlns:a16="http://schemas.microsoft.com/office/drawing/2014/main" val="2385059026"/>
+                  </a:ext>
+                </a:extLst>
+              </a:tr>
+              <a:tr h="376806">
+                <a:tc>
+                  <a:txBody>
+                    <a:bodyPr/>
+                    <a:lstStyle/>
+                    <a:p>
+                      <a:pPr marL="0" marR="0" lvl="0" indent="0" algn="l" defTabSz="914400" rtl="0" eaLnBrk="1" fontAlgn="auto" latinLnBrk="0" hangingPunct="1">
+                        <a:lnSpc>
+                          <a:spcPct val="100000"/>
+                        </a:lnSpc>
+                        <a:spcBef>
+                          <a:spcPts val="0"/>
+                        </a:spcBef>
+                        <a:spcAft>
+                          <a:spcPts val="0"/>
+                        </a:spcAft>
+                        <a:buClrTx/>
+                        <a:buSzTx/>
+                        <a:buFontTx/>
+                        <a:buNone/>
+                        <a:tabLst/>
+                        <a:defRPr/>
+                      </a:pPr>
+                      <a:r>
+                        <a:rPr lang="en-US" b="1" dirty="0"/>
+                        <a:t>Course Structure</a:t>
+                      </a:r>
+                    </a:p>
+                  </a:txBody>
+                  <a:tcPr>
+                    <a:lnR w="6350" cap="flat" cmpd="sng" algn="ctr">
+                      <a:solidFill>
+                        <a:schemeClr val="accent1"/>
+                      </a:solidFill>
+                      <a:prstDash val="solid"/>
+                      <a:round/>
+                      <a:headEnd type="none" w="med" len="med"/>
+                      <a:tailEnd type="none" w="med" len="med"/>
+                    </a:lnR>
+                    <a:lnT w="12700" cmpd="sng">
+                      <a:noFill/>
+                    </a:lnT>
+                    <a:noFill/>
+                  </a:tcPr>
+                </a:tc>
+                <a:tc>
+                  <a:txBody>
+                    <a:bodyPr/>
+                    <a:lstStyle/>
+                    <a:p>
+                      <a:r>
+                        <a:rPr lang="en-GB" dirty="0">
+                          <a:solidFill>
+                            <a:schemeClr val="bg1">
+                              <a:lumMod val="65000"/>
+                            </a:schemeClr>
+                          </a:solidFill>
+                        </a:rPr>
+                        <a:t>5</a:t>
+                      </a:r>
+                    </a:p>
+                  </a:txBody>
+                  <a:tcPr>
+                    <a:lnL w="6350" cap="flat" cmpd="sng" algn="ctr">
+                      <a:solidFill>
+                        <a:schemeClr val="accent1"/>
+                      </a:solidFill>
+                      <a:prstDash val="solid"/>
+                      <a:round/>
+                      <a:headEnd type="none" w="med" len="med"/>
+                      <a:tailEnd type="none" w="med" len="med"/>
+                    </a:lnL>
+                    <a:lnR w="6350" cap="flat" cmpd="sng" algn="ctr">
+                      <a:solidFill>
+                        <a:schemeClr val="accent5"/>
+                      </a:solidFill>
+                      <a:prstDash val="solid"/>
+                      <a:round/>
+                      <a:headEnd type="none" w="med" len="med"/>
+                      <a:tailEnd type="none" w="med" len="med"/>
+                    </a:lnR>
+                    <a:lnT w="12700" cmpd="sng">
+                      <a:noFill/>
+                    </a:lnT>
+                    <a:noFill/>
+                  </a:tcPr>
+                </a:tc>
+                <a:tc>
+                  <a:txBody>
+                    <a:bodyPr/>
+                    <a:lstStyle/>
+                    <a:p>
+                      <a:r>
+                        <a:rPr lang="en-GB" dirty="0"/>
+                        <a:t>7</a:t>
+                      </a:r>
+                    </a:p>
+                  </a:txBody>
+                  <a:tcPr>
+                    <a:lnL w="6350" cap="flat" cmpd="sng" algn="ctr">
+                      <a:solidFill>
+                        <a:schemeClr val="accent5"/>
+                      </a:solidFill>
+                      <a:prstDash val="solid"/>
+                      <a:round/>
+                      <a:headEnd type="none" w="med" len="med"/>
+                      <a:tailEnd type="none" w="med" len="med"/>
+                    </a:lnL>
+                    <a:lnR w="6350" cap="flat" cmpd="sng" algn="ctr">
+                      <a:solidFill>
+                        <a:schemeClr val="accent3"/>
+                      </a:solidFill>
+                      <a:prstDash val="solid"/>
+                      <a:round/>
+                      <a:headEnd type="none" w="med" len="med"/>
+                      <a:tailEnd type="none" w="med" len="med"/>
+                    </a:lnR>
+                    <a:lnT w="12700" cmpd="sng">
+                      <a:noFill/>
+                    </a:lnT>
+                    <a:noFill/>
+                  </a:tcPr>
+                </a:tc>
+                <a:tc>
+                  <a:txBody>
+                    <a:bodyPr/>
+                    <a:lstStyle/>
+                    <a:p>
+                      <a:pPr algn="ctr" rtl="0"/>
+                      <a:endParaRPr lang="en-GB" noProof="0" dirty="0"/>
+                    </a:p>
+                  </a:txBody>
+                  <a:tcPr anchor="ctr">
+                    <a:lnL w="6350" cap="flat" cmpd="sng" algn="ctr">
+                      <a:solidFill>
+                        <a:schemeClr val="accent3"/>
+                      </a:solidFill>
+                      <a:prstDash val="solid"/>
+                      <a:round/>
+                      <a:headEnd type="none" w="med" len="med"/>
+                      <a:tailEnd type="none" w="med" len="med"/>
+                    </a:lnL>
+                    <a:lnR w="6350" cap="flat" cmpd="sng" algn="ctr">
+                      <a:solidFill>
+                        <a:schemeClr val="accent4"/>
+                      </a:solidFill>
+                      <a:prstDash val="solid"/>
+                      <a:round/>
+                      <a:headEnd type="none" w="med" len="med"/>
+                      <a:tailEnd type="none" w="med" len="med"/>
+                    </a:lnR>
+                    <a:lnT w="12700" cmpd="sng">
+                      <a:noFill/>
+                    </a:lnT>
+                    <a:noFill/>
+                  </a:tcPr>
+                </a:tc>
+                <a:extLst>
+                  <a:ext uri="{0D108BD9-81ED-4DB2-BD59-A6C34878D82A}">
+                    <a16:rowId xmlns:a16="http://schemas.microsoft.com/office/drawing/2014/main" val="3783722433"/>
+                  </a:ext>
+                </a:extLst>
+              </a:tr>
+              <a:tr h="376806">
+                <a:tc>
+                  <a:txBody>
+                    <a:bodyPr/>
+                    <a:lstStyle/>
+                    <a:p>
+                      <a:pPr marL="0" marR="0" lvl="0" indent="0" algn="l" defTabSz="914400" rtl="0" eaLnBrk="1" fontAlgn="auto" latinLnBrk="0" hangingPunct="1">
+                        <a:lnSpc>
+                          <a:spcPct val="100000"/>
+                        </a:lnSpc>
+                        <a:spcBef>
+                          <a:spcPts val="0"/>
+                        </a:spcBef>
+                        <a:spcAft>
+                          <a:spcPts val="0"/>
+                        </a:spcAft>
+                        <a:buClrTx/>
+                        <a:buSzTx/>
+                        <a:buFontTx/>
+                        <a:buNone/>
+                        <a:tabLst/>
+                        <a:defRPr/>
+                      </a:pPr>
+                      <a:r>
+                        <a:rPr lang="en-US" b="1" dirty="0"/>
+                        <a:t>Content Quality</a:t>
+                      </a:r>
+                    </a:p>
+                  </a:txBody>
+                  <a:tcPr>
+                    <a:lnR w="6350" cap="flat" cmpd="sng" algn="ctr">
+                      <a:solidFill>
+                        <a:schemeClr val="accent1"/>
+                      </a:solidFill>
+                      <a:prstDash val="solid"/>
+                      <a:round/>
+                      <a:headEnd type="none" w="med" len="med"/>
+                      <a:tailEnd type="none" w="med" len="med"/>
+                    </a:lnR>
+                    <a:noFill/>
+                  </a:tcPr>
+                </a:tc>
+                <a:tc>
+                  <a:txBody>
+                    <a:bodyPr/>
+                    <a:lstStyle/>
+                    <a:p>
+                      <a:r>
+                        <a:rPr lang="en-GB" dirty="0">
+                          <a:solidFill>
+                            <a:schemeClr val="bg1">
+                              <a:lumMod val="65000"/>
+                            </a:schemeClr>
+                          </a:solidFill>
+                        </a:rPr>
+                        <a:t>9</a:t>
+                      </a:r>
+                    </a:p>
+                  </a:txBody>
+                  <a:tcPr>
+                    <a:lnL w="6350" cap="flat" cmpd="sng" algn="ctr">
+                      <a:solidFill>
+                        <a:schemeClr val="accent1"/>
+                      </a:solidFill>
+                      <a:prstDash val="solid"/>
+                      <a:round/>
+                      <a:headEnd type="none" w="med" len="med"/>
+                      <a:tailEnd type="none" w="med" len="med"/>
+                    </a:lnL>
+                    <a:lnR w="6350" cap="flat" cmpd="sng" algn="ctr">
+                      <a:solidFill>
+                        <a:schemeClr val="accent5"/>
+                      </a:solidFill>
+                      <a:prstDash val="solid"/>
+                      <a:round/>
+                      <a:headEnd type="none" w="med" len="med"/>
+                      <a:tailEnd type="none" w="med" len="med"/>
+                    </a:lnR>
+                    <a:noFill/>
+                  </a:tcPr>
+                </a:tc>
+                <a:tc>
+                  <a:txBody>
+                    <a:bodyPr/>
+                    <a:lstStyle/>
+                    <a:p>
+                      <a:r>
+                        <a:rPr lang="en-GB" dirty="0"/>
+                        <a:t>4</a:t>
+                      </a:r>
+                    </a:p>
+                  </a:txBody>
+                  <a:tcPr>
+                    <a:lnL w="6350" cap="flat" cmpd="sng" algn="ctr">
+                      <a:solidFill>
+                        <a:schemeClr val="accent5"/>
+                      </a:solidFill>
+                      <a:prstDash val="solid"/>
+                      <a:round/>
+                      <a:headEnd type="none" w="med" len="med"/>
+                      <a:tailEnd type="none" w="med" len="med"/>
+                    </a:lnL>
+                    <a:lnR w="6350" cap="flat" cmpd="sng" algn="ctr">
+                      <a:solidFill>
+                        <a:schemeClr val="accent3"/>
+                      </a:solidFill>
+                      <a:prstDash val="solid"/>
+                      <a:round/>
+                      <a:headEnd type="none" w="med" len="med"/>
+                      <a:tailEnd type="none" w="med" len="med"/>
+                    </a:lnR>
+                    <a:noFill/>
+                  </a:tcPr>
+                </a:tc>
+                <a:tc>
+                  <a:txBody>
+                    <a:bodyPr/>
+                    <a:lstStyle/>
+                    <a:p>
+                      <a:pPr algn="ctr" rtl="0"/>
+                      <a:endParaRPr lang="en-GB" noProof="0" dirty="0"/>
+                    </a:p>
+                  </a:txBody>
+                  <a:tcPr anchor="ctr">
+                    <a:lnL w="6350" cap="flat" cmpd="sng" algn="ctr">
+                      <a:solidFill>
+                        <a:schemeClr val="accent3"/>
+                      </a:solidFill>
+                      <a:prstDash val="solid"/>
+                      <a:round/>
+                      <a:headEnd type="none" w="med" len="med"/>
+                      <a:tailEnd type="none" w="med" len="med"/>
+                    </a:lnL>
+                    <a:lnR w="6350" cap="flat" cmpd="sng" algn="ctr">
+                      <a:solidFill>
+                        <a:schemeClr val="accent4"/>
+                      </a:solidFill>
+                      <a:prstDash val="solid"/>
+                      <a:round/>
+                      <a:headEnd type="none" w="med" len="med"/>
+                      <a:tailEnd type="none" w="med" len="med"/>
+                    </a:lnR>
+                    <a:noFill/>
+                  </a:tcPr>
+                </a:tc>
+                <a:extLst>
+                  <a:ext uri="{0D108BD9-81ED-4DB2-BD59-A6C34878D82A}">
+                    <a16:rowId xmlns:a16="http://schemas.microsoft.com/office/drawing/2014/main" val="1400497281"/>
+                  </a:ext>
+                </a:extLst>
+              </a:tr>
+              <a:tr h="376806">
+                <a:tc>
+                  <a:txBody>
+                    <a:bodyPr/>
+                    <a:lstStyle/>
+                    <a:p>
+                      <a:pPr marL="0" marR="0" lvl="0" indent="0" algn="l" defTabSz="914400" rtl="0" eaLnBrk="1" fontAlgn="auto" latinLnBrk="0" hangingPunct="1">
+                        <a:lnSpc>
+                          <a:spcPct val="100000"/>
+                        </a:lnSpc>
+                        <a:spcBef>
+                          <a:spcPts val="0"/>
+                        </a:spcBef>
+                        <a:spcAft>
+                          <a:spcPts val="0"/>
+                        </a:spcAft>
+                        <a:buClrTx/>
+                        <a:buSzTx/>
+                        <a:buFontTx/>
+                        <a:buNone/>
+                        <a:tabLst/>
+                        <a:defRPr/>
+                      </a:pPr>
+                      <a:r>
+                        <a:rPr lang="en-US" b="1" dirty="0"/>
+                        <a:t>Flow &amp; Interactivity</a:t>
+                      </a:r>
+                    </a:p>
+                  </a:txBody>
+                  <a:tcPr>
+                    <a:lnR w="6350" cap="flat" cmpd="sng" algn="ctr">
+                      <a:solidFill>
+                        <a:schemeClr val="accent1"/>
+                      </a:solidFill>
+                      <a:prstDash val="solid"/>
+                      <a:round/>
+                      <a:headEnd type="none" w="med" len="med"/>
+                      <a:tailEnd type="none" w="med" len="med"/>
+                    </a:lnR>
+                    <a:noFill/>
+                  </a:tcPr>
+                </a:tc>
+                <a:tc>
+                  <a:txBody>
+                    <a:bodyPr/>
+                    <a:lstStyle/>
+                    <a:p>
+                      <a:r>
+                        <a:rPr lang="en-GB" dirty="0">
+                          <a:solidFill>
+                            <a:schemeClr val="bg1">
+                              <a:lumMod val="65000"/>
+                            </a:schemeClr>
+                          </a:solidFill>
+                        </a:rPr>
+                        <a:t>6</a:t>
+                      </a:r>
+                    </a:p>
+                  </a:txBody>
+                  <a:tcPr>
+                    <a:lnL w="6350" cap="flat" cmpd="sng" algn="ctr">
+                      <a:solidFill>
+                        <a:schemeClr val="accent1"/>
+                      </a:solidFill>
+                      <a:prstDash val="solid"/>
+                      <a:round/>
+                      <a:headEnd type="none" w="med" len="med"/>
+                      <a:tailEnd type="none" w="med" len="med"/>
+                    </a:lnL>
+                    <a:lnR w="6350" cap="flat" cmpd="sng" algn="ctr">
+                      <a:solidFill>
+                        <a:schemeClr val="accent5"/>
+                      </a:solidFill>
+                      <a:prstDash val="solid"/>
+                      <a:round/>
+                      <a:headEnd type="none" w="med" len="med"/>
+                      <a:tailEnd type="none" w="med" len="med"/>
+                    </a:lnR>
+                    <a:noFill/>
+                  </a:tcPr>
+                </a:tc>
+                <a:tc>
+                  <a:txBody>
+                    <a:bodyPr/>
+                    <a:lstStyle/>
+                    <a:p>
+                      <a:r>
+                        <a:rPr lang="en-GB" dirty="0"/>
+                        <a:t>4</a:t>
+                      </a:r>
+                    </a:p>
+                  </a:txBody>
+                  <a:tcPr>
+                    <a:lnL w="6350" cap="flat" cmpd="sng" algn="ctr">
+                      <a:solidFill>
+                        <a:schemeClr val="accent5"/>
+                      </a:solidFill>
+                      <a:prstDash val="solid"/>
+                      <a:round/>
+                      <a:headEnd type="none" w="med" len="med"/>
+                      <a:tailEnd type="none" w="med" len="med"/>
+                    </a:lnL>
+                    <a:lnR w="6350" cap="flat" cmpd="sng" algn="ctr">
+                      <a:solidFill>
+                        <a:schemeClr val="accent3"/>
+                      </a:solidFill>
+                      <a:prstDash val="solid"/>
+                      <a:round/>
+                      <a:headEnd type="none" w="med" len="med"/>
+                      <a:tailEnd type="none" w="med" len="med"/>
+                    </a:lnR>
+                    <a:noFill/>
+                  </a:tcPr>
+                </a:tc>
+                <a:tc>
+                  <a:txBody>
+                    <a:bodyPr/>
+                    <a:lstStyle/>
+                    <a:p>
+                      <a:pPr algn="ctr" rtl="0"/>
+                      <a:endParaRPr lang="en-GB" noProof="0" dirty="0"/>
+                    </a:p>
+                  </a:txBody>
+                  <a:tcPr anchor="ctr">
+                    <a:lnL w="6350" cap="flat" cmpd="sng" algn="ctr">
+                      <a:solidFill>
+                        <a:schemeClr val="accent3"/>
+                      </a:solidFill>
+                      <a:prstDash val="solid"/>
+                      <a:round/>
+                      <a:headEnd type="none" w="med" len="med"/>
+                      <a:tailEnd type="none" w="med" len="med"/>
+                    </a:lnL>
+                    <a:lnR w="6350" cap="flat" cmpd="sng" algn="ctr">
+                      <a:solidFill>
+                        <a:schemeClr val="accent4"/>
+                      </a:solidFill>
+                      <a:prstDash val="solid"/>
+                      <a:round/>
+                      <a:headEnd type="none" w="med" len="med"/>
+                      <a:tailEnd type="none" w="med" len="med"/>
+                    </a:lnR>
+                    <a:noFill/>
+                  </a:tcPr>
+                </a:tc>
+                <a:extLst>
+                  <a:ext uri="{0D108BD9-81ED-4DB2-BD59-A6C34878D82A}">
+                    <a16:rowId xmlns:a16="http://schemas.microsoft.com/office/drawing/2014/main" val="567824203"/>
+                  </a:ext>
+                </a:extLst>
+              </a:tr>
+              <a:tr h="376806">
+                <a:tc>
+                  <a:txBody>
+                    <a:bodyPr/>
+                    <a:lstStyle/>
+                    <a:p>
+                      <a:pPr marL="0" marR="0" lvl="0" indent="0" algn="l" defTabSz="914400" rtl="0" eaLnBrk="1" fontAlgn="auto" latinLnBrk="0" hangingPunct="1">
+                        <a:lnSpc>
+                          <a:spcPct val="100000"/>
+                        </a:lnSpc>
+                        <a:spcBef>
+                          <a:spcPts val="0"/>
+                        </a:spcBef>
+                        <a:spcAft>
+                          <a:spcPts val="0"/>
+                        </a:spcAft>
+                        <a:buClrTx/>
+                        <a:buSzTx/>
+                        <a:buFontTx/>
+                        <a:buNone/>
+                        <a:tabLst/>
+                        <a:defRPr/>
+                      </a:pPr>
+                      <a:r>
+                        <a:rPr lang="en-US" b="1" dirty="0"/>
+                        <a:t>Pacing</a:t>
+                      </a:r>
+                    </a:p>
+                  </a:txBody>
+                  <a:tcPr>
+                    <a:lnR w="6350" cap="flat" cmpd="sng" algn="ctr">
+                      <a:solidFill>
+                        <a:schemeClr val="accent1"/>
+                      </a:solidFill>
+                      <a:prstDash val="solid"/>
+                      <a:round/>
+                      <a:headEnd type="none" w="med" len="med"/>
+                      <a:tailEnd type="none" w="med" len="med"/>
+                    </a:lnR>
+                    <a:noFill/>
+                  </a:tcPr>
+                </a:tc>
+                <a:tc>
+                  <a:txBody>
+                    <a:bodyPr/>
+                    <a:lstStyle/>
+                    <a:p>
+                      <a:r>
+                        <a:rPr lang="en-GB" dirty="0">
+                          <a:solidFill>
+                            <a:schemeClr val="bg1">
+                              <a:lumMod val="65000"/>
+                            </a:schemeClr>
+                          </a:solidFill>
+                        </a:rPr>
+                        <a:t>6</a:t>
+                      </a:r>
+                    </a:p>
+                  </a:txBody>
+                  <a:tcPr>
+                    <a:lnL w="6350" cap="flat" cmpd="sng" algn="ctr">
+                      <a:solidFill>
+                        <a:schemeClr val="accent1"/>
+                      </a:solidFill>
+                      <a:prstDash val="solid"/>
+                      <a:round/>
+                      <a:headEnd type="none" w="med" len="med"/>
+                      <a:tailEnd type="none" w="med" len="med"/>
+                    </a:lnL>
+                    <a:lnR w="6350" cap="flat" cmpd="sng" algn="ctr">
+                      <a:solidFill>
+                        <a:schemeClr val="accent5"/>
+                      </a:solidFill>
+                      <a:prstDash val="solid"/>
+                      <a:round/>
+                      <a:headEnd type="none" w="med" len="med"/>
+                      <a:tailEnd type="none" w="med" len="med"/>
+                    </a:lnR>
+                    <a:noFill/>
+                  </a:tcPr>
+                </a:tc>
+                <a:tc>
+                  <a:txBody>
+                    <a:bodyPr/>
+                    <a:lstStyle/>
+                    <a:p>
+                      <a:r>
+                        <a:rPr lang="en-GB" dirty="0"/>
+                        <a:t>7</a:t>
+                      </a:r>
+                    </a:p>
+                  </a:txBody>
+                  <a:tcPr>
+                    <a:lnL w="6350" cap="flat" cmpd="sng" algn="ctr">
+                      <a:solidFill>
+                        <a:schemeClr val="accent5"/>
+                      </a:solidFill>
+                      <a:prstDash val="solid"/>
+                      <a:round/>
+                      <a:headEnd type="none" w="med" len="med"/>
+                      <a:tailEnd type="none" w="med" len="med"/>
+                    </a:lnL>
+                    <a:lnR w="6350" cap="flat" cmpd="sng" algn="ctr">
+                      <a:solidFill>
+                        <a:schemeClr val="accent3"/>
+                      </a:solidFill>
+                      <a:prstDash val="solid"/>
+                      <a:round/>
+                      <a:headEnd type="none" w="med" len="med"/>
+                      <a:tailEnd type="none" w="med" len="med"/>
+                    </a:lnR>
+                    <a:noFill/>
+                  </a:tcPr>
+                </a:tc>
+                <a:tc>
+                  <a:txBody>
+                    <a:bodyPr/>
+                    <a:lstStyle/>
+                    <a:p>
+                      <a:pPr algn="ctr" rtl="0"/>
+                      <a:endParaRPr lang="en-GB" noProof="0" dirty="0"/>
+                    </a:p>
+                  </a:txBody>
+                  <a:tcPr anchor="ctr">
+                    <a:lnL w="6350" cap="flat" cmpd="sng" algn="ctr">
+                      <a:solidFill>
+                        <a:schemeClr val="accent3"/>
+                      </a:solidFill>
+                      <a:prstDash val="solid"/>
+                      <a:round/>
+                      <a:headEnd type="none" w="med" len="med"/>
+                      <a:tailEnd type="none" w="med" len="med"/>
+                    </a:lnL>
+                    <a:lnR w="6350" cap="flat" cmpd="sng" algn="ctr">
+                      <a:solidFill>
+                        <a:schemeClr val="accent4"/>
+                      </a:solidFill>
+                      <a:prstDash val="solid"/>
+                      <a:round/>
+                      <a:headEnd type="none" w="med" len="med"/>
+                      <a:tailEnd type="none" w="med" len="med"/>
+                    </a:lnR>
+                    <a:noFill/>
+                  </a:tcPr>
+                </a:tc>
+                <a:extLst>
+                  <a:ext uri="{0D108BD9-81ED-4DB2-BD59-A6C34878D82A}">
+                    <a16:rowId xmlns:a16="http://schemas.microsoft.com/office/drawing/2014/main" val="664053301"/>
+                  </a:ext>
+                </a:extLst>
+              </a:tr>
+              <a:tr h="376806">
+                <a:tc>
+                  <a:txBody>
+                    <a:bodyPr/>
+                    <a:lstStyle/>
+                    <a:p>
+                      <a:pPr marL="0" marR="0" lvl="0" indent="0" algn="l" defTabSz="914400" rtl="0" eaLnBrk="1" fontAlgn="auto" latinLnBrk="0" hangingPunct="1">
+                        <a:lnSpc>
+                          <a:spcPct val="100000"/>
+                        </a:lnSpc>
+                        <a:spcBef>
+                          <a:spcPts val="0"/>
+                        </a:spcBef>
+                        <a:spcAft>
+                          <a:spcPts val="0"/>
+                        </a:spcAft>
+                        <a:buClrTx/>
+                        <a:buSzTx/>
+                        <a:buFontTx/>
+                        <a:buNone/>
+                        <a:tabLst/>
+                        <a:defRPr/>
+                      </a:pPr>
+                      <a:r>
+                        <a:rPr lang="en-US" b="1" dirty="0"/>
+                        <a:t>Production &amp; Medium</a:t>
+                      </a:r>
+                    </a:p>
+                  </a:txBody>
+                  <a:tcPr>
+                    <a:lnR w="6350" cap="flat" cmpd="sng" algn="ctr">
+                      <a:solidFill>
+                        <a:schemeClr val="accent1"/>
+                      </a:solidFill>
+                      <a:prstDash val="solid"/>
+                      <a:round/>
+                      <a:headEnd type="none" w="med" len="med"/>
+                      <a:tailEnd type="none" w="med" len="med"/>
+                    </a:lnR>
+                    <a:noFill/>
+                  </a:tcPr>
+                </a:tc>
+                <a:tc>
+                  <a:txBody>
+                    <a:bodyPr/>
+                    <a:lstStyle/>
+                    <a:p>
+                      <a:r>
+                        <a:rPr lang="en-GB" dirty="0">
+                          <a:solidFill>
+                            <a:schemeClr val="bg1">
+                              <a:lumMod val="65000"/>
+                            </a:schemeClr>
+                          </a:solidFill>
+                        </a:rPr>
+                        <a:t>7 -&gt; 5</a:t>
+                      </a:r>
+                    </a:p>
+                  </a:txBody>
+                  <a:tcPr>
+                    <a:lnL w="6350" cap="flat" cmpd="sng" algn="ctr">
+                      <a:solidFill>
+                        <a:schemeClr val="accent1"/>
+                      </a:solidFill>
+                      <a:prstDash val="solid"/>
+                      <a:round/>
+                      <a:headEnd type="none" w="med" len="med"/>
+                      <a:tailEnd type="none" w="med" len="med"/>
+                    </a:lnL>
+                    <a:lnR w="6350" cap="flat" cmpd="sng" algn="ctr">
+                      <a:solidFill>
+                        <a:schemeClr val="accent5"/>
+                      </a:solidFill>
+                      <a:prstDash val="solid"/>
+                      <a:round/>
+                      <a:headEnd type="none" w="med" len="med"/>
+                      <a:tailEnd type="none" w="med" len="med"/>
+                    </a:lnR>
+                    <a:noFill/>
+                  </a:tcPr>
+                </a:tc>
+                <a:tc>
+                  <a:txBody>
+                    <a:bodyPr/>
+                    <a:lstStyle/>
+                    <a:p>
+                      <a:r>
+                        <a:rPr lang="en-GB" dirty="0"/>
+                        <a:t>7</a:t>
+                      </a:r>
+                    </a:p>
+                  </a:txBody>
+                  <a:tcPr>
+                    <a:lnL w="6350" cap="flat" cmpd="sng" algn="ctr">
+                      <a:solidFill>
+                        <a:schemeClr val="accent5"/>
+                      </a:solidFill>
+                      <a:prstDash val="solid"/>
+                      <a:round/>
+                      <a:headEnd type="none" w="med" len="med"/>
+                      <a:tailEnd type="none" w="med" len="med"/>
+                    </a:lnL>
+                    <a:lnR w="6350" cap="flat" cmpd="sng" algn="ctr">
+                      <a:solidFill>
+                        <a:schemeClr val="accent3"/>
+                      </a:solidFill>
+                      <a:prstDash val="solid"/>
+                      <a:round/>
+                      <a:headEnd type="none" w="med" len="med"/>
+                      <a:tailEnd type="none" w="med" len="med"/>
+                    </a:lnR>
+                    <a:noFill/>
+                  </a:tcPr>
+                </a:tc>
+                <a:tc>
+                  <a:txBody>
+                    <a:bodyPr/>
+                    <a:lstStyle/>
+                    <a:p>
+                      <a:pPr algn="ctr" rtl="0"/>
+                      <a:endParaRPr lang="en-GB" noProof="0"/>
+                    </a:p>
+                  </a:txBody>
+                  <a:tcPr anchor="ctr">
+                    <a:lnL w="6350" cap="flat" cmpd="sng" algn="ctr">
+                      <a:solidFill>
+                        <a:schemeClr val="accent3"/>
+                      </a:solidFill>
+                      <a:prstDash val="solid"/>
+                      <a:round/>
+                      <a:headEnd type="none" w="med" len="med"/>
+                      <a:tailEnd type="none" w="med" len="med"/>
+                    </a:lnL>
+                    <a:lnR w="6350" cap="flat" cmpd="sng" algn="ctr">
+                      <a:solidFill>
+                        <a:schemeClr val="accent4"/>
+                      </a:solidFill>
+                      <a:prstDash val="solid"/>
+                      <a:round/>
+                      <a:headEnd type="none" w="med" len="med"/>
+                      <a:tailEnd type="none" w="med" len="med"/>
+                    </a:lnR>
+                    <a:noFill/>
+                  </a:tcPr>
+                </a:tc>
+                <a:extLst>
+                  <a:ext uri="{0D108BD9-81ED-4DB2-BD59-A6C34878D82A}">
+                    <a16:rowId xmlns:a16="http://schemas.microsoft.com/office/drawing/2014/main" val="347733110"/>
+                  </a:ext>
+                </a:extLst>
+              </a:tr>
+              <a:tr h="376806">
+                <a:tc>
+                  <a:txBody>
+                    <a:bodyPr/>
+                    <a:lstStyle/>
+                    <a:p>
+                      <a:r>
+                        <a:rPr lang="en-US" b="1" dirty="0"/>
+                        <a:t>Value</a:t>
+                      </a:r>
+                    </a:p>
+                  </a:txBody>
+                  <a:tcPr>
+                    <a:lnR w="6350" cap="flat" cmpd="sng" algn="ctr">
+                      <a:solidFill>
+                        <a:schemeClr val="accent1"/>
+                      </a:solidFill>
+                      <a:prstDash val="solid"/>
+                      <a:round/>
+                      <a:headEnd type="none" w="med" len="med"/>
+                      <a:tailEnd type="none" w="med" len="med"/>
+                    </a:lnR>
+                    <a:noFill/>
+                  </a:tcPr>
+                </a:tc>
+                <a:tc>
+                  <a:txBody>
+                    <a:bodyPr/>
+                    <a:lstStyle/>
+                    <a:p>
+                      <a:r>
+                        <a:rPr lang="en-GB" dirty="0">
+                          <a:solidFill>
+                            <a:schemeClr val="bg1">
+                              <a:lumMod val="65000"/>
+                            </a:schemeClr>
+                          </a:solidFill>
+                        </a:rPr>
+                        <a:t>8</a:t>
+                      </a:r>
+                    </a:p>
+                  </a:txBody>
+                  <a:tcPr>
+                    <a:lnL w="6350" cap="flat" cmpd="sng" algn="ctr">
+                      <a:solidFill>
+                        <a:schemeClr val="accent1"/>
+                      </a:solidFill>
+                      <a:prstDash val="solid"/>
+                      <a:round/>
+                      <a:headEnd type="none" w="med" len="med"/>
+                      <a:tailEnd type="none" w="med" len="med"/>
+                    </a:lnL>
+                    <a:lnR w="6350" cap="flat" cmpd="sng" algn="ctr">
+                      <a:solidFill>
+                        <a:schemeClr val="accent5"/>
+                      </a:solidFill>
+                      <a:prstDash val="solid"/>
+                      <a:round/>
+                      <a:headEnd type="none" w="med" len="med"/>
+                      <a:tailEnd type="none" w="med" len="med"/>
+                    </a:lnR>
+                    <a:noFill/>
+                  </a:tcPr>
+                </a:tc>
+                <a:tc>
+                  <a:txBody>
+                    <a:bodyPr/>
+                    <a:lstStyle/>
+                    <a:p>
+                      <a:r>
+                        <a:rPr lang="en-GB" dirty="0"/>
+                        <a:t>5</a:t>
+                      </a:r>
+                    </a:p>
+                  </a:txBody>
+                  <a:tcPr>
+                    <a:lnL w="6350" cap="flat" cmpd="sng" algn="ctr">
+                      <a:solidFill>
+                        <a:schemeClr val="accent5"/>
+                      </a:solidFill>
+                      <a:prstDash val="solid"/>
+                      <a:round/>
+                      <a:headEnd type="none" w="med" len="med"/>
+                      <a:tailEnd type="none" w="med" len="med"/>
+                    </a:lnL>
+                    <a:lnR w="6350" cap="flat" cmpd="sng" algn="ctr">
+                      <a:solidFill>
+                        <a:schemeClr val="accent3"/>
+                      </a:solidFill>
+                      <a:prstDash val="solid"/>
+                      <a:round/>
+                      <a:headEnd type="none" w="med" len="med"/>
+                      <a:tailEnd type="none" w="med" len="med"/>
+                    </a:lnR>
+                    <a:noFill/>
+                  </a:tcPr>
+                </a:tc>
+                <a:tc>
+                  <a:txBody>
+                    <a:bodyPr/>
+                    <a:lstStyle/>
+                    <a:p>
+                      <a:pPr algn="ctr" rtl="0"/>
+                      <a:endParaRPr lang="en-GB" noProof="0"/>
+                    </a:p>
+                  </a:txBody>
+                  <a:tcPr anchor="ctr">
+                    <a:lnL w="6350" cap="flat" cmpd="sng" algn="ctr">
+                      <a:solidFill>
+                        <a:schemeClr val="accent3"/>
+                      </a:solidFill>
+                      <a:prstDash val="solid"/>
+                      <a:round/>
+                      <a:headEnd type="none" w="med" len="med"/>
+                      <a:tailEnd type="none" w="med" len="med"/>
+                    </a:lnL>
+                    <a:lnR w="6350" cap="flat" cmpd="sng" algn="ctr">
+                      <a:solidFill>
+                        <a:schemeClr val="accent4"/>
+                      </a:solidFill>
+                      <a:prstDash val="solid"/>
+                      <a:round/>
+                      <a:headEnd type="none" w="med" len="med"/>
+                      <a:tailEnd type="none" w="med" len="med"/>
+                    </a:lnR>
+                    <a:noFill/>
+                  </a:tcPr>
+                </a:tc>
+                <a:extLst>
+                  <a:ext uri="{0D108BD9-81ED-4DB2-BD59-A6C34878D82A}">
+                    <a16:rowId xmlns:a16="http://schemas.microsoft.com/office/drawing/2014/main" val="930197925"/>
+                  </a:ext>
+                </a:extLst>
+              </a:tr>
+              <a:tr h="376806">
+                <a:tc>
+                  <a:txBody>
+                    <a:bodyPr/>
+                    <a:lstStyle/>
+                    <a:p>
+                      <a:pPr marL="0" marR="0" lvl="0" indent="0" algn="l" defTabSz="914400" rtl="0" eaLnBrk="1" fontAlgn="auto" latinLnBrk="0" hangingPunct="1">
+                        <a:lnSpc>
+                          <a:spcPct val="100000"/>
+                        </a:lnSpc>
+                        <a:spcBef>
+                          <a:spcPts val="0"/>
+                        </a:spcBef>
+                        <a:spcAft>
+                          <a:spcPts val="0"/>
+                        </a:spcAft>
+                        <a:buClrTx/>
+                        <a:buSzTx/>
+                        <a:buFontTx/>
+                        <a:buNone/>
+                        <a:tabLst/>
+                        <a:defRPr/>
+                      </a:pPr>
+                      <a:r>
+                        <a:rPr lang="en-US" b="1" dirty="0"/>
+                        <a:t>Je ne sais quoi	</a:t>
+                      </a:r>
+                    </a:p>
+                  </a:txBody>
+                  <a:tcPr>
+                    <a:lnR w="6350" cap="flat" cmpd="sng" algn="ctr">
+                      <a:solidFill>
+                        <a:schemeClr val="accent1"/>
+                      </a:solidFill>
+                      <a:prstDash val="solid"/>
+                      <a:round/>
+                      <a:headEnd type="none" w="med" len="med"/>
+                      <a:tailEnd type="none" w="med" len="med"/>
+                    </a:lnR>
+                    <a:noFill/>
+                  </a:tcPr>
+                </a:tc>
+                <a:tc>
+                  <a:txBody>
+                    <a:bodyPr/>
+                    <a:lstStyle/>
+                    <a:p>
+                      <a:r>
+                        <a:rPr lang="en-GB" dirty="0">
+                          <a:solidFill>
+                            <a:schemeClr val="bg1">
+                              <a:lumMod val="65000"/>
+                            </a:schemeClr>
+                          </a:solidFill>
+                        </a:rPr>
+                        <a:t>2</a:t>
+                      </a:r>
+                    </a:p>
+                  </a:txBody>
+                  <a:tcPr>
+                    <a:lnL w="6350" cap="flat" cmpd="sng" algn="ctr">
+                      <a:solidFill>
+                        <a:schemeClr val="accent1"/>
+                      </a:solidFill>
+                      <a:prstDash val="solid"/>
+                      <a:round/>
+                      <a:headEnd type="none" w="med" len="med"/>
+                      <a:tailEnd type="none" w="med" len="med"/>
+                    </a:lnL>
+                    <a:lnR w="6350" cap="flat" cmpd="sng" algn="ctr">
+                      <a:solidFill>
+                        <a:schemeClr val="accent5"/>
+                      </a:solidFill>
+                      <a:prstDash val="solid"/>
+                      <a:round/>
+                      <a:headEnd type="none" w="med" len="med"/>
+                      <a:tailEnd type="none" w="med" len="med"/>
+                    </a:lnR>
+                    <a:noFill/>
+                  </a:tcPr>
+                </a:tc>
+                <a:tc>
+                  <a:txBody>
+                    <a:bodyPr/>
+                    <a:lstStyle/>
+                    <a:p>
+                      <a:r>
+                        <a:rPr lang="en-GB" dirty="0"/>
+                        <a:t>1</a:t>
+                      </a:r>
+                    </a:p>
+                  </a:txBody>
+                  <a:tcPr>
+                    <a:lnL w="6350" cap="flat" cmpd="sng" algn="ctr">
+                      <a:solidFill>
+                        <a:schemeClr val="accent5"/>
+                      </a:solidFill>
+                      <a:prstDash val="solid"/>
+                      <a:round/>
+                      <a:headEnd type="none" w="med" len="med"/>
+                      <a:tailEnd type="none" w="med" len="med"/>
+                    </a:lnL>
+                    <a:lnR w="6350" cap="flat" cmpd="sng" algn="ctr">
+                      <a:solidFill>
+                        <a:schemeClr val="accent3"/>
+                      </a:solidFill>
+                      <a:prstDash val="solid"/>
+                      <a:round/>
+                      <a:headEnd type="none" w="med" len="med"/>
+                      <a:tailEnd type="none" w="med" len="med"/>
+                    </a:lnR>
+                    <a:noFill/>
+                  </a:tcPr>
+                </a:tc>
+                <a:tc>
+                  <a:txBody>
+                    <a:bodyPr/>
+                    <a:lstStyle/>
+                    <a:p>
+                      <a:pPr algn="ctr" rtl="0"/>
+                      <a:endParaRPr lang="en-GB" noProof="0"/>
+                    </a:p>
+                  </a:txBody>
+                  <a:tcPr anchor="ctr">
+                    <a:lnL w="6350" cap="flat" cmpd="sng" algn="ctr">
+                      <a:solidFill>
+                        <a:schemeClr val="accent3"/>
+                      </a:solidFill>
+                      <a:prstDash val="solid"/>
+                      <a:round/>
+                      <a:headEnd type="none" w="med" len="med"/>
+                      <a:tailEnd type="none" w="med" len="med"/>
+                    </a:lnL>
+                    <a:lnR w="6350" cap="flat" cmpd="sng" algn="ctr">
+                      <a:solidFill>
+                        <a:schemeClr val="accent4"/>
+                      </a:solidFill>
+                      <a:prstDash val="solid"/>
+                      <a:round/>
+                      <a:headEnd type="none" w="med" len="med"/>
+                      <a:tailEnd type="none" w="med" len="med"/>
+                    </a:lnR>
+                    <a:noFill/>
+                  </a:tcPr>
+                </a:tc>
+                <a:extLst>
+                  <a:ext uri="{0D108BD9-81ED-4DB2-BD59-A6C34878D82A}">
+                    <a16:rowId xmlns:a16="http://schemas.microsoft.com/office/drawing/2014/main" val="3064648766"/>
+                  </a:ext>
+                </a:extLst>
+              </a:tr>
+              <a:tr h="376806">
+                <a:tc>
+                  <a:txBody>
+                    <a:bodyPr/>
+                    <a:lstStyle/>
+                    <a:p>
+                      <a:pPr marL="0" marR="0" lvl="0" indent="0" algn="l" defTabSz="914400" rtl="0" eaLnBrk="1" fontAlgn="auto" latinLnBrk="0" hangingPunct="1">
+                        <a:lnSpc>
+                          <a:spcPct val="100000"/>
+                        </a:lnSpc>
+                        <a:spcBef>
+                          <a:spcPts val="0"/>
+                        </a:spcBef>
+                        <a:spcAft>
+                          <a:spcPts val="0"/>
+                        </a:spcAft>
+                        <a:buClrTx/>
+                        <a:buSzTx/>
+                        <a:buFontTx/>
+                        <a:buNone/>
+                        <a:tabLst/>
+                        <a:defRPr/>
+                      </a:pPr>
+                      <a:r>
+                        <a:rPr lang="en-US" b="1" dirty="0"/>
+                        <a:t>Total</a:t>
+                      </a:r>
+                    </a:p>
+                  </a:txBody>
+                  <a:tcPr>
+                    <a:lnR w="6350" cap="flat" cmpd="sng" algn="ctr">
+                      <a:solidFill>
+                        <a:schemeClr val="accent1"/>
+                      </a:solidFill>
+                      <a:prstDash val="solid"/>
+                      <a:round/>
+                      <a:headEnd type="none" w="med" len="med"/>
+                      <a:tailEnd type="none" w="med" len="med"/>
+                    </a:lnR>
+                    <a:noFill/>
+                  </a:tcPr>
+                </a:tc>
+                <a:tc>
+                  <a:txBody>
+                    <a:bodyPr/>
+                    <a:lstStyle/>
+                    <a:p>
+                      <a:pPr algn="ctr"/>
+                      <a:r>
+                        <a:rPr lang="en-GB" b="1" dirty="0">
+                          <a:solidFill>
+                            <a:schemeClr val="bg1">
+                              <a:lumMod val="65000"/>
+                            </a:schemeClr>
+                          </a:solidFill>
+                        </a:rPr>
+                        <a:t>45 -&gt; 43 / 75</a:t>
+                      </a:r>
+                    </a:p>
+                  </a:txBody>
+                  <a:tcPr>
+                    <a:lnL w="6350" cap="flat" cmpd="sng" algn="ctr">
+                      <a:solidFill>
+                        <a:schemeClr val="accent1"/>
+                      </a:solidFill>
+                      <a:prstDash val="solid"/>
+                      <a:round/>
+                      <a:headEnd type="none" w="med" len="med"/>
+                      <a:tailEnd type="none" w="med" len="med"/>
+                    </a:lnL>
+                    <a:lnR w="6350" cap="flat" cmpd="sng" algn="ctr">
+                      <a:solidFill>
+                        <a:schemeClr val="accent5"/>
+                      </a:solidFill>
+                      <a:prstDash val="solid"/>
+                      <a:round/>
+                      <a:headEnd type="none" w="med" len="med"/>
+                      <a:tailEnd type="none" w="med" len="med"/>
+                    </a:lnR>
+                    <a:noFill/>
+                  </a:tcPr>
+                </a:tc>
+                <a:tc>
+                  <a:txBody>
+                    <a:bodyPr/>
+                    <a:lstStyle/>
+                    <a:p>
+                      <a:pPr marL="0" algn="ctr" defTabSz="914400" rtl="0" eaLnBrk="1" latinLnBrk="0" hangingPunct="1"/>
+                      <a:r>
+                        <a:rPr lang="en-GB" sz="1800" b="1" kern="1200" dirty="0">
+                          <a:solidFill>
+                            <a:schemeClr val="accent5"/>
+                          </a:solidFill>
+                          <a:latin typeface="+mn-lt"/>
+                          <a:ea typeface="+mn-ea"/>
+                          <a:cs typeface="+mn-cs"/>
+                        </a:rPr>
+                        <a:t>38/75</a:t>
+                      </a:r>
+                    </a:p>
+                  </a:txBody>
+                  <a:tcPr anchor="ctr">
+                    <a:lnL w="6350" cap="flat" cmpd="sng" algn="ctr">
+                      <a:solidFill>
+                        <a:schemeClr val="accent5"/>
+                      </a:solidFill>
+                      <a:prstDash val="solid"/>
+                      <a:round/>
+                      <a:headEnd type="none" w="med" len="med"/>
+                      <a:tailEnd type="none" w="med" len="med"/>
+                    </a:lnL>
+                    <a:lnR w="6350" cap="flat" cmpd="sng" algn="ctr">
+                      <a:solidFill>
+                        <a:schemeClr val="accent3"/>
+                      </a:solidFill>
+                      <a:prstDash val="solid"/>
+                      <a:round/>
+                      <a:headEnd type="none" w="med" len="med"/>
+                      <a:tailEnd type="none" w="med" len="med"/>
+                    </a:lnR>
+                    <a:noFill/>
+                  </a:tcPr>
+                </a:tc>
+                <a:tc>
+                  <a:txBody>
+                    <a:bodyPr/>
+                    <a:lstStyle/>
+                    <a:p>
+                      <a:pPr algn="ctr" rtl="0"/>
+                      <a:endParaRPr lang="en-GB" noProof="0" dirty="0"/>
+                    </a:p>
+                  </a:txBody>
+                  <a:tcPr anchor="ctr">
+                    <a:lnL w="6350" cap="flat" cmpd="sng" algn="ctr">
+                      <a:solidFill>
+                        <a:schemeClr val="accent3"/>
+                      </a:solidFill>
+                      <a:prstDash val="solid"/>
+                      <a:round/>
+                      <a:headEnd type="none" w="med" len="med"/>
+                      <a:tailEnd type="none" w="med" len="med"/>
+                    </a:lnL>
+                    <a:lnR w="6350" cap="flat" cmpd="sng" algn="ctr">
+                      <a:solidFill>
+                        <a:schemeClr val="accent4"/>
+                      </a:solidFill>
+                      <a:prstDash val="solid"/>
+                      <a:round/>
+                      <a:headEnd type="none" w="med" len="med"/>
+                      <a:tailEnd type="none" w="med" len="med"/>
+                    </a:lnR>
+                    <a:noFill/>
+                  </a:tcPr>
+                </a:tc>
+                <a:extLst>
+                  <a:ext uri="{0D108BD9-81ED-4DB2-BD59-A6C34878D82A}">
+                    <a16:rowId xmlns:a16="http://schemas.microsoft.com/office/drawing/2014/main" val="1919923748"/>
+                  </a:ext>
+                </a:extLst>
+              </a:tr>
+            </a:tbl>
+          </a:graphicData>
+        </a:graphic>
+      </p:graphicFrame>
+      <p:sp>
+        <p:nvSpPr>
+          <p:cNvPr id="7" name="Slide Number Placeholder 5">
+            <a:extLst>
+              <a:ext uri="{FF2B5EF4-FFF2-40B4-BE49-F238E27FC236}">
+                <a16:creationId xmlns:a16="http://schemas.microsoft.com/office/drawing/2014/main" id="{21DC1DE5-1A2A-2A26-5B3F-4F3F12896D3D}"/>
+              </a:ext>
+            </a:extLst>
+          </p:cNvPr>
+          <p:cNvSpPr>
+            <a:spLocks noGrp="1"/>
+          </p:cNvSpPr>
+          <p:nvPr>
+            <p:ph type="sldNum" sz="quarter" idx="12"/>
+          </p:nvPr>
+        </p:nvSpPr>
+        <p:spPr>
+          <a:xfrm>
+            <a:off x="8610600" y="6356350"/>
+            <a:ext cx="2743200" cy="365125"/>
+          </a:xfrm>
+        </p:spPr>
+        <p:txBody>
+          <a:bodyPr rtlCol="0"/>
+          <a:lstStyle/>
+          <a:p>
+            <a:pPr rtl="0"/>
+            <a:fld id="{D8DA9DAA-006C-4F4B-980E-E3DF019B24E2}" type="slidenum">
+              <a:rPr lang="en-GB" b="1" cap="all" spc="100" smtClean="0">
+                <a:solidFill>
+                  <a:schemeClr val="accent2"/>
+                </a:solidFill>
+              </a:rPr>
+              <a:t>14</a:t>
+            </a:fld>
+            <a:endParaRPr lang="en-GB" b="1" cap="all" spc="100">
+              <a:solidFill>
+                <a:schemeClr val="accent2"/>
+              </a:solidFill>
+            </a:endParaRPr>
+          </a:p>
+        </p:txBody>
+      </p:sp>
+    </p:spTree>
+    <p:extLst>
+      <p:ext uri="{BB962C8B-B14F-4D97-AF65-F5344CB8AC3E}">
+        <p14:creationId xmlns:p14="http://schemas.microsoft.com/office/powerpoint/2010/main" val="2599071480"/>
+      </p:ext>
+    </p:extLst>
+  </p:cSld>
+  <p:clrMapOvr>
+    <a:masterClrMapping/>
+  </p:clrMapOvr>
+</p:sld>
+</file>
+
+<file path=ppt/slides/slide15.xml><?xml version="1.0" encoding="utf-8"?>
 <p:sld xmlns:a="http://schemas.openxmlformats.org/drawingml/2006/main" xmlns:r="http://schemas.openxmlformats.org/officeDocument/2006/relationships" xmlns:p="http://schemas.openxmlformats.org/presentationml/2006/main">
   <p:cSld>
     <p:spTree>
@@ -15370,7 +17289,7 @@
                   <a:schemeClr val="accent2"/>
                 </a:solidFill>
               </a:rPr>
-              <a:t>14</a:t>
+              <a:t>15</a:t>
             </a:fld>
             <a:endParaRPr lang="en-GB" b="1" cap="all" spc="100">
               <a:solidFill>
@@ -15831,7 +17750,7 @@
 </p:sld>
 </file>
 
-<file path=ppt/slides/slide15.xml><?xml version="1.0" encoding="utf-8"?>
+<file path=ppt/slides/slide16.xml><?xml version="1.0" encoding="utf-8"?>
 <p:sld xmlns:a="http://schemas.openxmlformats.org/drawingml/2006/main" xmlns:r="http://schemas.openxmlformats.org/officeDocument/2006/relationships" xmlns:p="http://schemas.openxmlformats.org/presentationml/2006/main">
   <p:cSld>
     <p:spTree>
@@ -15923,10 +17842,10 @@
           <p:nvPr/>
         </p:nvPicPr>
         <p:blipFill>
-          <a:blip r:embed="rId3">
+          <a:blip>
             <a:extLst>
               <a:ext uri="{96DAC541-7B7A-43D3-8B79-37D633B846F1}">
-                <asvg:svgBlip xmlns:asvg="http://schemas.microsoft.com/office/drawing/2016/SVG/main" r:embed="rId4"/>
+                <asvg:svgBlip xmlns:asvg="http://schemas.microsoft.com/office/drawing/2016/SVG/main" r:embed="rId3"/>
               </a:ext>
             </a:extLst>
           </a:blip>
@@ -16094,7 +18013,7 @@
           <p:nvPr/>
         </p:nvPicPr>
         <p:blipFill rotWithShape="1">
-          <a:blip r:embed="rId5"/>
+          <a:blip r:embed="rId4"/>
           <a:srcRect l="16" r="16"/>
           <a:stretch/>
         </p:blipFill>
@@ -16222,7 +18141,7 @@
           <p:nvPr/>
         </p:nvPicPr>
         <p:blipFill rotWithShape="1">
-          <a:blip r:embed="rId6"/>
+          <a:blip r:embed="rId5"/>
           <a:srcRect t="347" b="347"/>
           <a:stretch/>
         </p:blipFill>
@@ -16398,10 +18317,10 @@
           <p:nvPr/>
         </p:nvPicPr>
         <p:blipFill>
-          <a:blip r:embed="rId7">
+          <a:blip>
             <a:extLst>
               <a:ext uri="{96DAC541-7B7A-43D3-8B79-37D633B846F1}">
-                <asvg:svgBlip xmlns:asvg="http://schemas.microsoft.com/office/drawing/2016/SVG/main" r:embed="rId8"/>
+                <asvg:svgBlip xmlns:asvg="http://schemas.microsoft.com/office/drawing/2016/SVG/main" r:embed="rId6"/>
               </a:ext>
             </a:extLst>
           </a:blip>
@@ -16592,10 +18511,10 @@
           <p:nvPr/>
         </p:nvPicPr>
         <p:blipFill>
-          <a:blip r:embed="rId4">
+          <a:blip>
             <a:extLst>
               <a:ext uri="{96DAC541-7B7A-43D3-8B79-37D633B846F1}">
-                <asvg:svgBlip xmlns:asvg="http://schemas.microsoft.com/office/drawing/2016/SVG/main" r:embed="rId5"/>
+                <asvg:svgBlip xmlns:asvg="http://schemas.microsoft.com/office/drawing/2016/SVG/main" r:embed="rId4"/>
               </a:ext>
             </a:extLst>
           </a:blip>
@@ -16628,10 +18547,10 @@
           <p:nvPr/>
         </p:nvPicPr>
         <p:blipFill>
-          <a:blip r:embed="rId6">
+          <a:blip>
             <a:extLst>
               <a:ext uri="{96DAC541-7B7A-43D3-8B79-37D633B846F1}">
-                <asvg:svgBlip xmlns:asvg="http://schemas.microsoft.com/office/drawing/2016/SVG/main" r:embed="rId7"/>
+                <asvg:svgBlip xmlns:asvg="http://schemas.microsoft.com/office/drawing/2016/SVG/main" r:embed="rId5"/>
               </a:ext>
             </a:extLst>
           </a:blip>
@@ -16664,10 +18583,10 @@
           <p:nvPr/>
         </p:nvPicPr>
         <p:blipFill>
-          <a:blip r:embed="rId8">
+          <a:blip>
             <a:extLst>
               <a:ext uri="{96DAC541-7B7A-43D3-8B79-37D633B846F1}">
-                <asvg:svgBlip xmlns:asvg="http://schemas.microsoft.com/office/drawing/2016/SVG/main" r:embed="rId9"/>
+                <asvg:svgBlip xmlns:asvg="http://schemas.microsoft.com/office/drawing/2016/SVG/main" r:embed="rId6"/>
               </a:ext>
             </a:extLst>
           </a:blip>
@@ -16700,10 +18619,10 @@
           <p:nvPr/>
         </p:nvPicPr>
         <p:blipFill>
-          <a:blip r:embed="rId10">
+          <a:blip>
             <a:extLst>
               <a:ext uri="{96DAC541-7B7A-43D3-8B79-37D633B846F1}">
-                <asvg:svgBlip xmlns:asvg="http://schemas.microsoft.com/office/drawing/2016/SVG/main" r:embed="rId11"/>
+                <asvg:svgBlip xmlns:asvg="http://schemas.microsoft.com/office/drawing/2016/SVG/main" r:embed="rId7"/>
               </a:ext>
             </a:extLst>
           </a:blip>
@@ -16736,10 +18655,10 @@
           <p:nvPr/>
         </p:nvPicPr>
         <p:blipFill>
-          <a:blip r:embed="rId12">
+          <a:blip>
             <a:extLst>
               <a:ext uri="{96DAC541-7B7A-43D3-8B79-37D633B846F1}">
-                <asvg:svgBlip xmlns:asvg="http://schemas.microsoft.com/office/drawing/2016/SVG/main" r:embed="rId13"/>
+                <asvg:svgBlip xmlns:asvg="http://schemas.microsoft.com/office/drawing/2016/SVG/main" r:embed="rId8"/>
               </a:ext>
             </a:extLst>
           </a:blip>
@@ -19518,10 +21437,10 @@
           <p:nvPr/>
         </p:nvPicPr>
         <p:blipFill>
-          <a:blip r:embed="rId3">
+          <a:blip>
             <a:extLst>
               <a:ext uri="{96DAC541-7B7A-43D3-8B79-37D633B846F1}">
-                <asvg:svgBlip xmlns:asvg="http://schemas.microsoft.com/office/drawing/2016/SVG/main" r:embed="rId4"/>
+                <asvg:svgBlip xmlns:asvg="http://schemas.microsoft.com/office/drawing/2016/SVG/main" r:embed="rId3"/>
               </a:ext>
             </a:extLst>
           </a:blip>
@@ -19554,7 +21473,7 @@
           <p:nvPr/>
         </p:nvPicPr>
         <p:blipFill>
-          <a:blip r:embed="rId5"/>
+          <a:blip r:embed="rId4"/>
           <a:stretch>
             <a:fillRect/>
           </a:stretch>
@@ -19584,10 +21503,10 @@
           <p:nvPr/>
         </p:nvPicPr>
         <p:blipFill>
-          <a:blip r:embed="rId6">
+          <a:blip>
             <a:extLst>
               <a:ext uri="{96DAC541-7B7A-43D3-8B79-37D633B846F1}">
-                <asvg:svgBlip xmlns:asvg="http://schemas.microsoft.com/office/drawing/2016/SVG/main" r:embed="rId7"/>
+                <asvg:svgBlip xmlns:asvg="http://schemas.microsoft.com/office/drawing/2016/SVG/main" r:embed="rId5"/>
               </a:ext>
             </a:extLst>
           </a:blip>
@@ -19620,7 +21539,7 @@
           <p:nvPr/>
         </p:nvPicPr>
         <p:blipFill>
-          <a:blip r:embed="rId8"/>
+          <a:blip r:embed="rId6"/>
           <a:stretch>
             <a:fillRect/>
           </a:stretch>
@@ -19650,10 +21569,10 @@
           <p:nvPr/>
         </p:nvPicPr>
         <p:blipFill>
-          <a:blip r:embed="rId9">
+          <a:blip>
             <a:extLst>
               <a:ext uri="{96DAC541-7B7A-43D3-8B79-37D633B846F1}">
-                <asvg:svgBlip xmlns:asvg="http://schemas.microsoft.com/office/drawing/2016/SVG/main" r:embed="rId10"/>
+                <asvg:svgBlip xmlns:asvg="http://schemas.microsoft.com/office/drawing/2016/SVG/main" r:embed="rId7"/>
               </a:ext>
             </a:extLst>
           </a:blip>
@@ -21405,6 +23324,15 @@
 </file>
 
 <file path=customXml/item1.xml><?xml version="1.0" encoding="utf-8"?>
+<?mso-contentType ?>
+<FormTemplates xmlns="http://schemas.microsoft.com/sharepoint/v3/contenttype/forms">
+  <Display>DocumentLibraryForm</Display>
+  <Edit>DocumentLibraryForm</Edit>
+  <New>DocumentLibraryForm</New>
+</FormTemplates>
+</file>
+
+<file path=customXml/item2.xml><?xml version="1.0" encoding="utf-8"?>
 <ct:contentTypeSchema xmlns:ct="http://schemas.microsoft.com/office/2006/metadata/contentType" xmlns:ma="http://schemas.microsoft.com/office/2006/metadata/properties/metaAttributes" ct:_="" ma:_="" ma:contentTypeName="Document" ma:contentTypeID="0x01010079F111ED35F8CC479449609E8A0923A6" ma:contentTypeVersion="12" ma:contentTypeDescription="Create a new document." ma:contentTypeScope="" ma:versionID="426e97fa315356fffbdcd9876fe988c2">
   <xsd:schema xmlns:xsd="http://www.w3.org/2001/XMLSchema" xmlns:xs="http://www.w3.org/2001/XMLSchema" xmlns:p="http://schemas.microsoft.com/office/2006/metadata/properties" xmlns:ns2="71af3243-3dd4-4a8d-8c0d-dd76da1f02a5" xmlns:ns3="16c05727-aa75-4e4a-9b5f-8a80a1165891" targetNamespace="http://schemas.microsoft.com/office/2006/metadata/properties" ma:root="true" ma:fieldsID="14b8f0def80e6d70ce3def20c90759ae" ns2:_="" ns3:_="">
     <xsd:import namespace="71af3243-3dd4-4a8d-8c0d-dd76da1f02a5"/>
@@ -21625,15 +23553,6 @@
 </ct:contentTypeSchema>
 </file>
 
-<file path=customXml/item2.xml><?xml version="1.0" encoding="utf-8"?>
-<?mso-contentType ?>
-<FormTemplates xmlns="http://schemas.microsoft.com/sharepoint/v3/contenttype/forms">
-  <Display>DocumentLibraryForm</Display>
-  <Edit>DocumentLibraryForm</Edit>
-  <New>DocumentLibraryForm</New>
-</FormTemplates>
-</file>
-
 <file path=customXml/item3.xml><?xml version="1.0" encoding="utf-8"?>
 <p:properties xmlns:p="http://schemas.microsoft.com/office/2006/metadata/properties" xmlns:xsi="http://www.w3.org/2001/XMLSchema-instance" xmlns:pc="http://schemas.microsoft.com/office/infopath/2007/PartnerControls">
   <documentManagement>
@@ -21644,6 +23563,14 @@
 </file>
 
 <file path=customXml/itemProps1.xml><?xml version="1.0" encoding="utf-8"?>
+<ds:datastoreItem xmlns:ds="http://schemas.openxmlformats.org/officeDocument/2006/customXml" ds:itemID="{3C8E00D1-8EA3-4E42-801D-0253E1EAFC21}">
+  <ds:schemaRefs>
+    <ds:schemaRef ds:uri="http://schemas.microsoft.com/sharepoint/v3/contenttype/forms"/>
+  </ds:schemaRefs>
+</ds:datastoreItem>
+</file>
+
+<file path=customXml/itemProps2.xml><?xml version="1.0" encoding="utf-8"?>
 <ds:datastoreItem xmlns:ds="http://schemas.openxmlformats.org/officeDocument/2006/customXml" ds:itemID="{ABC329F5-30EE-4BF7-AA2A-B837B51416B4}">
   <ds:schemaRefs>
     <ds:schemaRef ds:uri="http://schemas.microsoft.com/office/2006/metadata/contentType"/>
@@ -21662,14 +23589,6 @@
 </ds:datastoreItem>
 </file>
 
-<file path=customXml/itemProps2.xml><?xml version="1.0" encoding="utf-8"?>
-<ds:datastoreItem xmlns:ds="http://schemas.openxmlformats.org/officeDocument/2006/customXml" ds:itemID="{3C8E00D1-8EA3-4E42-801D-0253E1EAFC21}">
-  <ds:schemaRefs>
-    <ds:schemaRef ds:uri="http://schemas.microsoft.com/sharepoint/v3/contenttype/forms"/>
-  </ds:schemaRefs>
-</ds:datastoreItem>
-</file>
-
 <file path=customXml/itemProps3.xml><?xml version="1.0" encoding="utf-8"?>
 <ds:datastoreItem xmlns:ds="http://schemas.openxmlformats.org/officeDocument/2006/customXml" ds:itemID="{99919F73-B6C2-4A43-95E2-833EC48925FE}">
   <ds:schemaRefs>

</xml_diff>